<commit_message>
docs: fix text clipping in deck card and subtitle boxes
</commit_message>
<xml_diff>
--- a/docs/NEXT-Africa-Deck.pptx
+++ b/docs/NEXT-Africa-Deck.pptx
@@ -2950,7 +2950,7 @@
         <p:spPr>
           <a:xfrm>
             <a:off x="777240" y="1417320"/>
-            <a:ext cx="9966960" cy="384048"/>
+            <a:ext cx="9966960" cy="566928"/>
           </a:xfrm>
           <a:prstGeom prst="rect">
             <a:avLst/>
@@ -3473,7 +3473,7 @@
         <p:spPr>
           <a:xfrm>
             <a:off x="777240" y="1417320"/>
-            <a:ext cx="9966960" cy="384048"/>
+            <a:ext cx="9966960" cy="566928"/>
           </a:xfrm>
           <a:prstGeom prst="rect">
             <a:avLst/>
@@ -4207,7 +4207,7 @@
         <p:spPr>
           <a:xfrm>
             <a:off x="777240" y="1417320"/>
-            <a:ext cx="9966960" cy="384048"/>
+            <a:ext cx="9966960" cy="566928"/>
           </a:xfrm>
           <a:prstGeom prst="rect">
             <a:avLst/>
@@ -5112,7 +5112,7 @@
         <p:spPr>
           <a:xfrm>
             <a:off x="777240" y="1417320"/>
-            <a:ext cx="9966960" cy="384048"/>
+            <a:ext cx="9966960" cy="566928"/>
           </a:xfrm>
           <a:prstGeom prst="rect">
             <a:avLst/>
@@ -5951,7 +5951,7 @@
         <p:spPr>
           <a:xfrm>
             <a:off x="777240" y="1417320"/>
-            <a:ext cx="9966960" cy="384048"/>
+            <a:ext cx="9966960" cy="566928"/>
           </a:xfrm>
           <a:prstGeom prst="rect">
             <a:avLst/>
@@ -7903,7 +7903,7 @@
         <p:spPr>
           <a:xfrm>
             <a:off x="777240" y="1417320"/>
-            <a:ext cx="9966960" cy="384048"/>
+            <a:ext cx="9966960" cy="566928"/>
           </a:xfrm>
           <a:prstGeom prst="rect">
             <a:avLst/>
@@ -8030,12 +8030,12 @@
         </p:nvSpPr>
         <p:spPr>
           <a:xfrm>
-            <a:off x="777240" y="3429000"/>
-            <a:ext cx="5143500" cy="1051560"/>
+            <a:off x="777240" y="3291840"/>
+            <a:ext cx="5143500" cy="1207008"/>
           </a:xfrm>
           <a:prstGeom prst="roundRect">
             <a:avLst>
-              <a:gd name="adj" fmla="val 5217"/>
+              <a:gd name="adj" fmla="val 4545"/>
             </a:avLst>
           </a:prstGeom>
           <a:solidFill>
@@ -8057,7 +8057,7 @@
         </p:nvSpPr>
         <p:spPr>
           <a:xfrm>
-            <a:off x="1033272" y="3611880"/>
+            <a:off x="1033272" y="3474720"/>
             <a:ext cx="4631436" cy="310896"/>
           </a:xfrm>
           <a:prstGeom prst="rect">
@@ -8096,8 +8096,8 @@
         </p:nvSpPr>
         <p:spPr>
           <a:xfrm>
-            <a:off x="1033272" y="3959352"/>
-            <a:ext cx="4631436" cy="365760"/>
+            <a:off x="1033272" y="3822192"/>
+            <a:ext cx="4631436" cy="521208"/>
           </a:xfrm>
           <a:prstGeom prst="rect">
             <a:avLst/>
@@ -8121,7 +8121,7 @@
                 <a:ea typeface="Segoe UI" pitchFamily="34" charset="-122"/>
                 <a:cs typeface="Segoe UI" pitchFamily="34" charset="-120"/>
               </a:rPr>
-              <a:t>Assume you block time deliberately. Most African work is reactive and negotiated in the moment.</a:t>
+              <a:t>Assume you block time deliberately. Our users negotiate the day in the moment.</a:t>
             </a:r>
             <a:endParaRPr lang="en-US" sz="1150" dirty="0"/>
           </a:p>
@@ -8135,12 +8135,12 @@
         </p:nvSpPr>
         <p:spPr>
           <a:xfrm>
-            <a:off x="6240780" y="3429000"/>
-            <a:ext cx="5143500" cy="1051560"/>
+            <a:off x="6240780" y="3291840"/>
+            <a:ext cx="5143500" cy="1207008"/>
           </a:xfrm>
           <a:prstGeom prst="roundRect">
             <a:avLst>
-              <a:gd name="adj" fmla="val 5217"/>
+              <a:gd name="adj" fmla="val 4545"/>
             </a:avLst>
           </a:prstGeom>
           <a:solidFill>
@@ -8162,7 +8162,7 @@
         </p:nvSpPr>
         <p:spPr>
           <a:xfrm>
-            <a:off x="6496812" y="3611880"/>
+            <a:off x="6496812" y="3474720"/>
             <a:ext cx="4631436" cy="310896"/>
           </a:xfrm>
           <a:prstGeom prst="rect">
@@ -8201,8 +8201,8 @@
         </p:nvSpPr>
         <p:spPr>
           <a:xfrm>
-            <a:off x="6496812" y="3959352"/>
-            <a:ext cx="4631436" cy="365760"/>
+            <a:off x="6496812" y="3822192"/>
+            <a:ext cx="4631436" cy="521208"/>
           </a:xfrm>
           <a:prstGeom prst="rect">
             <a:avLst/>
@@ -8226,7 +8226,7 @@
                 <a:ea typeface="Segoe UI" pitchFamily="34" charset="-122"/>
                 <a:cs typeface="Segoe UI" pitchFamily="34" charset="-120"/>
               </a:rPr>
-              <a:t>Assume a desktop and stable bandwidth. Data cost and patchy signal are real constraints.</a:t>
+              <a:t>Assume a desktop and steady bandwidth. Data cost and patchy signal are real.</a:t>
             </a:r>
             <a:endParaRPr lang="en-US" sz="1150" dirty="0"/>
           </a:p>
@@ -8240,12 +8240,12 @@
         </p:nvSpPr>
         <p:spPr>
           <a:xfrm>
-            <a:off x="777240" y="4754880"/>
-            <a:ext cx="5143500" cy="1051560"/>
+            <a:off x="777240" y="4773168"/>
+            <a:ext cx="5143500" cy="1207008"/>
           </a:xfrm>
           <a:prstGeom prst="roundRect">
             <a:avLst>
-              <a:gd name="adj" fmla="val 5217"/>
+              <a:gd name="adj" fmla="val 4545"/>
             </a:avLst>
           </a:prstGeom>
           <a:solidFill>
@@ -8267,7 +8267,7 @@
         </p:nvSpPr>
         <p:spPr>
           <a:xfrm>
-            <a:off x="1033272" y="4937760"/>
+            <a:off x="1033272" y="4956048"/>
             <a:ext cx="4631436" cy="310896"/>
           </a:xfrm>
           <a:prstGeom prst="rect">
@@ -8306,8 +8306,8 @@
         </p:nvSpPr>
         <p:spPr>
           <a:xfrm>
-            <a:off x="1033272" y="5285232"/>
-            <a:ext cx="4631436" cy="365760"/>
+            <a:off x="1033272" y="5303520"/>
+            <a:ext cx="4631436" cy="521208"/>
           </a:xfrm>
           <a:prstGeom prst="rect">
             <a:avLst/>
@@ -8331,7 +8331,7 @@
                 <a:ea typeface="Segoe UI" pitchFamily="34" charset="-122"/>
                 <a:cs typeface="Segoe UI" pitchFamily="34" charset="-120"/>
               </a:rPr>
-              <a:t>Assume email is the record of work. WhatsApp threads and voice notes carry the actual load.</a:t>
+              <a:t>Assume email is the record of work. Threads and voice notes carry the load.</a:t>
             </a:r>
             <a:endParaRPr lang="en-US" sz="1150" dirty="0"/>
           </a:p>
@@ -8345,12 +8345,12 @@
         </p:nvSpPr>
         <p:spPr>
           <a:xfrm>
-            <a:off x="6240780" y="4754880"/>
-            <a:ext cx="5143500" cy="1051560"/>
+            <a:off x="6240780" y="4773168"/>
+            <a:ext cx="5143500" cy="1207008"/>
           </a:xfrm>
           <a:prstGeom prst="roundRect">
             <a:avLst>
-              <a:gd name="adj" fmla="val 5217"/>
+              <a:gd name="adj" fmla="val 4545"/>
             </a:avLst>
           </a:prstGeom>
           <a:solidFill>
@@ -8372,7 +8372,7 @@
         </p:nvSpPr>
         <p:spPr>
           <a:xfrm>
-            <a:off x="6496812" y="4937760"/>
+            <a:off x="6496812" y="4956048"/>
             <a:ext cx="4631436" cy="310896"/>
           </a:xfrm>
           <a:prstGeom prst="rect">
@@ -8411,8 +8411,8 @@
         </p:nvSpPr>
         <p:spPr>
           <a:xfrm>
-            <a:off x="6496812" y="5285232"/>
-            <a:ext cx="4631436" cy="365760"/>
+            <a:off x="6496812" y="5303520"/>
+            <a:ext cx="4631436" cy="521208"/>
           </a:xfrm>
           <a:prstGeom prst="rect">
             <a:avLst/>
@@ -8436,7 +8436,7 @@
                 <a:ea typeface="Segoe UI" pitchFamily="34" charset="-122"/>
                 <a:cs typeface="Segoe UI" pitchFamily="34" charset="-120"/>
               </a:rPr>
-              <a:t>Priced for salaried teams. Our users are students, freelancers, traders and solo operators.</a:t>
+              <a:t>Priced for salaried teams. Our users are students, traders and solo operators.</a:t>
             </a:r>
             <a:endParaRPr lang="en-US" sz="1150" dirty="0"/>
           </a:p>
@@ -8664,7 +8664,7 @@
         <p:spPr>
           <a:xfrm>
             <a:off x="777240" y="1417320"/>
-            <a:ext cx="9966960" cy="384048"/>
+            <a:ext cx="9966960" cy="566928"/>
           </a:xfrm>
           <a:prstGeom prst="rect">
             <a:avLst/>
@@ -9699,7 +9699,7 @@
         <p:spPr>
           <a:xfrm>
             <a:off x="777240" y="1417320"/>
-            <a:ext cx="9966960" cy="384048"/>
+            <a:ext cx="9966960" cy="566928"/>
           </a:xfrm>
           <a:prstGeom prst="rect">
             <a:avLst/>
@@ -10222,7 +10222,7 @@
         <p:spPr>
           <a:xfrm>
             <a:off x="777240" y="1417320"/>
-            <a:ext cx="9966960" cy="384048"/>
+            <a:ext cx="9966960" cy="566928"/>
           </a:xfrm>
           <a:prstGeom prst="rect">
             <a:avLst/>
@@ -10745,7 +10745,7 @@
         <p:spPr>
           <a:xfrm>
             <a:off x="777240" y="1417320"/>
-            <a:ext cx="9966960" cy="384048"/>
+            <a:ext cx="9966960" cy="566928"/>
           </a:xfrm>
           <a:prstGeom prst="rect">
             <a:avLst/>
@@ -11268,7 +11268,7 @@
         <p:spPr>
           <a:xfrm>
             <a:off x="777240" y="1417320"/>
-            <a:ext cx="9966960" cy="384048"/>
+            <a:ext cx="9966960" cy="566928"/>
           </a:xfrm>
           <a:prstGeom prst="rect">
             <a:avLst/>
@@ -11791,7 +11791,7 @@
         <p:spPr>
           <a:xfrm>
             <a:off x="777240" y="1417320"/>
-            <a:ext cx="9966960" cy="384048"/>
+            <a:ext cx="9966960" cy="566928"/>
           </a:xfrm>
           <a:prstGeom prst="rect">
             <a:avLst/>

</xml_diff>